<commit_message>
Fiches outils: RTU (en cours: Hole Opener)
Co-Authored-By: Claude Sonnet 5.5 <noreply@anthropic.com>
Claude-Session: https://claude.ai/code/session_01XPwnZBmWUGhvYebrP3X3Z2
</commit_message>
<xml_diff>
--- a/fiches_outils/Fiche_technique_HoleOpener.pptx
+++ b/fiches_outils/Fiche_technique_HoleOpener.pptx
@@ -9091,7 +9091,7 @@
         </p:blipFill>
         <p:spPr>
           <a:xfrm>
-            <a:off x="711200" y="7137400"/>
+            <a:off x="711200" y="7061200"/>
             <a:ext cx="1499016" cy="3048000"/>
           </a:xfrm>
           <a:prstGeom prst="rect">
@@ -9107,8 +9107,8 @@
         </p:nvSpPr>
         <p:spPr>
           <a:xfrm>
-            <a:off x="2260600" y="7112000"/>
-            <a:ext cx="1905000" cy="177800"/>
+            <a:off x="2260600" y="7035800"/>
+            <a:ext cx="1778000" cy="177800"/>
           </a:xfrm>
           <a:prstGeom prst="rect">
             <a:avLst/>
@@ -9149,8 +9149,8 @@
         </p:nvSpPr>
         <p:spPr>
           <a:xfrm>
-            <a:off x="2260600" y="7315200"/>
-            <a:ext cx="1854200" cy="127000"/>
+            <a:off x="2260600" y="7239000"/>
+            <a:ext cx="1778000" cy="127000"/>
           </a:xfrm>
           <a:prstGeom prst="rect">
             <a:avLst/>
@@ -9448,8 +9448,8 @@
         </p:nvSpPr>
         <p:spPr>
           <a:xfrm>
-            <a:off x="2260600" y="8864600"/>
-            <a:ext cx="1905000" cy="177800"/>
+            <a:off x="2260600" y="8813800"/>
+            <a:ext cx="1778000" cy="177800"/>
           </a:xfrm>
           <a:prstGeom prst="rect">
             <a:avLst/>
@@ -9490,8 +9490,8 @@
         </p:nvSpPr>
         <p:spPr>
           <a:xfrm>
-            <a:off x="2260600" y="9067800"/>
-            <a:ext cx="1854200" cy="127000"/>
+            <a:off x="2260600" y="9017000"/>
+            <a:ext cx="1778000" cy="127000"/>
           </a:xfrm>
           <a:prstGeom prst="rect">
             <a:avLst/>
@@ -9651,7 +9651,7 @@
         </p:nvSpPr>
         <p:spPr>
           <a:xfrm>
-            <a:off x="4089400" y="7112000"/>
+            <a:off x="4089400" y="7035800"/>
             <a:ext cx="2755900" cy="177800"/>
           </a:xfrm>
           <a:prstGeom prst="rect">
@@ -9694,7 +9694,7 @@
           <p:nvPr/>
         </p:nvGraphicFramePr>
         <p:xfrm>
-          <a:off x="4089400" y="7302500"/>
+          <a:off x="4089400" y="7226300"/>
           <a:ext cx="2755900" cy="698500"/>
         </p:xfrm>
         <a:graphic>
@@ -10436,7 +10436,7 @@
                           <a:cs typeface="Ubuntu Mono"/>
                           <a:sym typeface="Ubuntu Mono"/>
                         </a:rPr>
-                        <a:t>Button (TCI)</a:t>
+                        <a:t>Button type</a:t>
                       </a:r>
                     </a:p>
                   </a:txBody>
@@ -10600,7 +10600,7 @@
                           <a:cs typeface="Ubuntu Mono"/>
                           <a:sym typeface="Ubuntu Mono"/>
                         </a:rPr>
-                        <a:t>Hard, TCI</a:t>
+                        <a:t>Extr. hard</a:t>
                       </a:r>
                     </a:p>
                   </a:txBody>
@@ -10654,7 +10654,7 @@
                           <a:cs typeface="Ubuntu Mono"/>
                           <a:sym typeface="Ubuntu Mono"/>
                         </a:rPr>
-                        <a:t>Extremely hard</a:t>
+                        <a:t>TCI button</a:t>
                       </a:r>
                     </a:p>
                   </a:txBody>
@@ -10809,8 +10809,8 @@
         </p:nvSpPr>
         <p:spPr>
           <a:xfrm>
-            <a:off x="4089400" y="8026400"/>
-            <a:ext cx="2755900" cy="228600"/>
+            <a:off x="4089400" y="7950200"/>
+            <a:ext cx="2755900" cy="114300"/>
           </a:xfrm>
           <a:prstGeom prst="rect">
             <a:avLst/>
@@ -10841,7 +10841,7 @@
                 <a:cs typeface="Ubuntu Mono"/>
                 <a:sym typeface="Ubuntu Mono"/>
               </a:rPr>
-              <a:t>Guideline for 19-3/4 - 26 in. holes (lower sizes need less weight and higher rpm).</a:t>
+              <a:t>Guideline for 19-3/4 - 26 in. holes; smaller sizes need less weight.</a:t>
             </a:r>
           </a:p>
         </p:txBody>
@@ -10854,7 +10854,7 @@
         </p:nvSpPr>
         <p:spPr>
           <a:xfrm>
-            <a:off x="4089400" y="8229600"/>
+            <a:off x="4089400" y="8102600"/>
             <a:ext cx="2755900" cy="177800"/>
           </a:xfrm>
           <a:prstGeom prst="rect">
@@ -10897,7 +10897,7 @@
           <p:nvPr/>
         </p:nvGraphicFramePr>
         <p:xfrm>
-          <a:off x="4089400" y="8420100"/>
+          <a:off x="4089400" y="8293100"/>
           <a:ext cx="2755900" cy="558800"/>
         </p:xfrm>
         <a:graphic>
@@ -11094,7 +11094,7 @@
                           <a:cs typeface="Ubuntu Mono"/>
                           <a:sym typeface="Ubuntu Mono"/>
                         </a:rPr>
-                        <a:t>26</a:t>
+                        <a:t>18 - 26</a:t>
                       </a:r>
                     </a:p>
                   </a:txBody>
@@ -11577,8 +11577,8 @@
         </p:nvSpPr>
         <p:spPr>
           <a:xfrm>
-            <a:off x="4089400" y="9004300"/>
-            <a:ext cx="2755900" cy="228600"/>
+            <a:off x="4089400" y="8877300"/>
+            <a:ext cx="2755900" cy="114300"/>
           </a:xfrm>
           <a:prstGeom prst="rect">
             <a:avLst/>
@@ -11609,7 +11609,7 @@
                 <a:cs typeface="Ubuntu Mono"/>
                 <a:sym typeface="Ubuntu Mono"/>
               </a:rPr>
-              <a:t>Cutter gauge is as dressed, not ground. Applies to milled tooth and TCI.</a:t>
+              <a:t>Gauge as dressed, not ground; milled tooth and TCI.</a:t>
             </a:r>
           </a:p>
         </p:txBody>
@@ -11622,7 +11622,7 @@
         </p:nvSpPr>
         <p:spPr>
           <a:xfrm>
-            <a:off x="4089400" y="9182100"/>
+            <a:off x="4089400" y="9017000"/>
             <a:ext cx="2755900" cy="177800"/>
           </a:xfrm>
           <a:prstGeom prst="rect">
@@ -11664,7 +11664,7 @@
         </p:nvSpPr>
         <p:spPr>
           <a:xfrm>
-            <a:off x="4089400" y="9372600"/>
+            <a:off x="4089400" y="9207500"/>
             <a:ext cx="2755900" cy="508000"/>
           </a:xfrm>
           <a:prstGeom prst="rect">
@@ -11696,7 +11696,7 @@
                 <a:cs typeface="Ubuntu Mono"/>
                 <a:sym typeface="Ubuntu Mono"/>
               </a:rPr>
-              <a:t>Cone-segment arms, replaceable nozzles, bottom box for bit or bullnose. One body takes several arm sizes. Opens up to 36 in.; milled tooth, TCI or PDC cones. Soft to medium-hard formations.</a:t>
+              <a:t>Cone-arm hole opener, up to 36 in.; one body takes several arm sizes. Bottom box for bit or bullnose. Milled tooth, TCI or PDC cones; soft to medium-hard formations.</a:t>
             </a:r>
           </a:p>
         </p:txBody>
@@ -11710,7 +11710,7 @@
           <p:nvPr/>
         </p:nvGraphicFramePr>
         <p:xfrm>
-          <a:off x="4089400" y="9829800"/>
+          <a:off x="4089400" y="9537700"/>
           <a:ext cx="2755900" cy="698500"/>
         </p:xfrm>
         <a:graphic>
@@ -11718,10 +11718,10 @@
             <a:tbl>
               <a:tblPr/>
               <a:tblGrid>
-                <a:gridCol w="431800"/>
+                <a:gridCol w="381000"/>
+                <a:gridCol w="838200"/>
                 <a:gridCol w="812800"/>
-                <a:gridCol w="762000"/>
-                <a:gridCol w="406400"/>
+                <a:gridCol w="381000"/>
                 <a:gridCol w="342900"/>
               </a:tblGrid>
               <a:tr h="139700">
@@ -11732,11 +11732,11 @@
                     <a:p>
                       <a:pPr algn="ctr">
                         <a:lnSpc>
-                          <a:spcPts val="740"/>
-                        </a:lnSpc>
-                      </a:pPr>
-                      <a:r>
-                        <a:rPr sz="580" b="1">
+                          <a:spcPts val="719"/>
+                        </a:lnSpc>
+                      </a:pPr>
+                      <a:r>
+                        <a:rPr sz="560" b="1">
                           <a:solidFill>
                             <a:srgbClr val="FEFEFF"/>
                           </a:solidFill>
@@ -11786,11 +11786,11 @@
                     <a:p>
                       <a:pPr algn="ctr">
                         <a:lnSpc>
-                          <a:spcPts val="740"/>
-                        </a:lnSpc>
-                      </a:pPr>
-                      <a:r>
-                        <a:rPr sz="580" b="1">
+                          <a:spcPts val="719"/>
+                        </a:lnSpc>
+                      </a:pPr>
+                      <a:r>
+                        <a:rPr sz="560" b="1">
                           <a:solidFill>
                             <a:srgbClr val="FEFEFF"/>
                           </a:solidFill>
@@ -11840,11 +11840,11 @@
                     <a:p>
                       <a:pPr algn="ctr">
                         <a:lnSpc>
-                          <a:spcPts val="740"/>
-                        </a:lnSpc>
-                      </a:pPr>
-                      <a:r>
-                        <a:rPr sz="580" b="1">
+                          <a:spcPts val="719"/>
+                        </a:lnSpc>
+                      </a:pPr>
+                      <a:r>
+                        <a:rPr sz="560" b="1">
                           <a:solidFill>
                             <a:srgbClr val="FEFEFF"/>
                           </a:solidFill>
@@ -11894,11 +11894,11 @@
                     <a:p>
                       <a:pPr algn="ctr">
                         <a:lnSpc>
-                          <a:spcPts val="740"/>
-                        </a:lnSpc>
-                      </a:pPr>
-                      <a:r>
-                        <a:rPr sz="580" b="1">
+                          <a:spcPts val="719"/>
+                        </a:lnSpc>
+                      </a:pPr>
+                      <a:r>
+                        <a:rPr sz="560" b="1">
                           <a:solidFill>
                             <a:srgbClr val="FEFEFF"/>
                           </a:solidFill>
@@ -11948,11 +11948,11 @@
                     <a:p>
                       <a:pPr algn="ctr">
                         <a:lnSpc>
-                          <a:spcPts val="740"/>
-                        </a:lnSpc>
-                      </a:pPr>
-                      <a:r>
-                        <a:rPr sz="580" b="1">
+                          <a:spcPts val="719"/>
+                        </a:lnSpc>
+                      </a:pPr>
+                      <a:r>
+                        <a:rPr sz="560" b="1">
                           <a:solidFill>
                             <a:srgbClr val="FEFEFF"/>
                           </a:solidFill>
@@ -12004,11 +12004,11 @@
                     <a:p>
                       <a:pPr algn="ctr">
                         <a:lnSpc>
-                          <a:spcPts val="740"/>
-                        </a:lnSpc>
-                      </a:pPr>
-                      <a:r>
-                        <a:rPr sz="580" b="0">
+                          <a:spcPts val="719"/>
+                        </a:lnSpc>
+                      </a:pPr>
+                      <a:r>
+                        <a:rPr sz="560" b="0">
                           <a:solidFill>
                             <a:srgbClr val="FEFEFF"/>
                           </a:solidFill>
@@ -12058,11 +12058,11 @@
                     <a:p>
                       <a:pPr algn="ctr">
                         <a:lnSpc>
-                          <a:spcPts val="740"/>
-                        </a:lnSpc>
-                      </a:pPr>
-                      <a:r>
-                        <a:rPr sz="580" b="0">
+                          <a:spcPts val="719"/>
+                        </a:lnSpc>
+                      </a:pPr>
+                      <a:r>
+                        <a:rPr sz="560" b="0">
                           <a:solidFill>
                             <a:srgbClr val="000000"/>
                           </a:solidFill>
@@ -12112,11 +12112,11 @@
                     <a:p>
                       <a:pPr algn="ctr">
                         <a:lnSpc>
-                          <a:spcPts val="740"/>
-                        </a:lnSpc>
-                      </a:pPr>
-                      <a:r>
-                        <a:rPr sz="580" b="0">
+                          <a:spcPts val="719"/>
+                        </a:lnSpc>
+                      </a:pPr>
+                      <a:r>
+                        <a:rPr sz="560" b="0">
                           <a:solidFill>
                             <a:srgbClr val="000000"/>
                           </a:solidFill>
@@ -12166,11 +12166,11 @@
                     <a:p>
                       <a:pPr algn="ctr">
                         <a:lnSpc>
-                          <a:spcPts val="740"/>
-                        </a:lnSpc>
-                      </a:pPr>
-                      <a:r>
-                        <a:rPr sz="580" b="0">
+                          <a:spcPts val="719"/>
+                        </a:lnSpc>
+                      </a:pPr>
+                      <a:r>
+                        <a:rPr sz="560" b="0">
                           <a:solidFill>
                             <a:srgbClr val="000000"/>
                           </a:solidFill>
@@ -12220,11 +12220,11 @@
                     <a:p>
                       <a:pPr algn="ctr">
                         <a:lnSpc>
-                          <a:spcPts val="740"/>
-                        </a:lnSpc>
-                      </a:pPr>
-                      <a:r>
-                        <a:rPr sz="580" b="0">
+                          <a:spcPts val="719"/>
+                        </a:lnSpc>
+                      </a:pPr>
+                      <a:r>
+                        <a:rPr sz="560" b="0">
                           <a:solidFill>
                             <a:srgbClr val="000000"/>
                           </a:solidFill>
@@ -12276,11 +12276,11 @@
                     <a:p>
                       <a:pPr algn="ctr">
                         <a:lnSpc>
-                          <a:spcPts val="740"/>
-                        </a:lnSpc>
-                      </a:pPr>
-                      <a:r>
-                        <a:rPr sz="580" b="0">
+                          <a:spcPts val="719"/>
+                        </a:lnSpc>
+                      </a:pPr>
+                      <a:r>
+                        <a:rPr sz="560" b="0">
                           <a:solidFill>
                             <a:srgbClr val="FEFEFF"/>
                           </a:solidFill>
@@ -12330,11 +12330,11 @@
                     <a:p>
                       <a:pPr algn="ctr">
                         <a:lnSpc>
-                          <a:spcPts val="740"/>
-                        </a:lnSpc>
-                      </a:pPr>
-                      <a:r>
-                        <a:rPr sz="580" b="0">
+                          <a:spcPts val="719"/>
+                        </a:lnSpc>
+                      </a:pPr>
+                      <a:r>
+                        <a:rPr sz="560" b="0">
                           <a:solidFill>
                             <a:srgbClr val="000000"/>
                           </a:solidFill>
@@ -12343,7 +12343,7 @@
                           <a:cs typeface="Ubuntu Mono"/>
                           <a:sym typeface="Ubuntu Mono"/>
                         </a:rPr>
-                        <a:t>12-1/4 / 14-3/4</a:t>
+                        <a:t>12-1/4, 14-3/4</a:t>
                       </a:r>
                     </a:p>
                   </a:txBody>
@@ -12384,11 +12384,11 @@
                     <a:p>
                       <a:pPr algn="ctr">
                         <a:lnSpc>
-                          <a:spcPts val="740"/>
-                        </a:lnSpc>
-                      </a:pPr>
-                      <a:r>
-                        <a:rPr sz="580" b="0">
+                          <a:spcPts val="719"/>
+                        </a:lnSpc>
+                      </a:pPr>
+                      <a:r>
+                        <a:rPr sz="560" b="0">
                           <a:solidFill>
                             <a:srgbClr val="000000"/>
                           </a:solidFill>
@@ -12397,7 +12397,7 @@
                           <a:cs typeface="Ubuntu Mono"/>
                           <a:sym typeface="Ubuntu Mono"/>
                         </a:rPr>
-                        <a:t>8-1/2 / 9-1/2</a:t>
+                        <a:t>8-1/2, 9-1/2</a:t>
                       </a:r>
                     </a:p>
                   </a:txBody>
@@ -12438,11 +12438,11 @@
                     <a:p>
                       <a:pPr algn="ctr">
                         <a:lnSpc>
-                          <a:spcPts val="740"/>
-                        </a:lnSpc>
-                      </a:pPr>
-                      <a:r>
-                        <a:rPr sz="580" b="0">
+                          <a:spcPts val="719"/>
+                        </a:lnSpc>
+                      </a:pPr>
+                      <a:r>
+                        <a:rPr sz="560" b="0">
                           <a:solidFill>
                             <a:srgbClr val="000000"/>
                           </a:solidFill>
@@ -12492,11 +12492,11 @@
                     <a:p>
                       <a:pPr algn="ctr">
                         <a:lnSpc>
-                          <a:spcPts val="740"/>
-                        </a:lnSpc>
-                      </a:pPr>
-                      <a:r>
-                        <a:rPr sz="580" b="0">
+                          <a:spcPts val="719"/>
+                        </a:lnSpc>
+                      </a:pPr>
+                      <a:r>
+                        <a:rPr sz="560" b="0">
                           <a:solidFill>
                             <a:srgbClr val="000000"/>
                           </a:solidFill>
@@ -12548,11 +12548,11 @@
                     <a:p>
                       <a:pPr algn="ctr">
                         <a:lnSpc>
-                          <a:spcPts val="740"/>
-                        </a:lnSpc>
-                      </a:pPr>
-                      <a:r>
-                        <a:rPr sz="580" b="0">
+                          <a:spcPts val="719"/>
+                        </a:lnSpc>
+                      </a:pPr>
+                      <a:r>
+                        <a:rPr sz="560" b="0">
                           <a:solidFill>
                             <a:srgbClr val="FEFEFF"/>
                           </a:solidFill>
@@ -12602,11 +12602,11 @@
                     <a:p>
                       <a:pPr algn="ctr">
                         <a:lnSpc>
-                          <a:spcPts val="740"/>
-                        </a:lnSpc>
-                      </a:pPr>
-                      <a:r>
-                        <a:rPr sz="580" b="0">
+                          <a:spcPts val="719"/>
+                        </a:lnSpc>
+                      </a:pPr>
+                      <a:r>
+                        <a:rPr sz="560" b="0">
                           <a:solidFill>
                             <a:srgbClr val="000000"/>
                           </a:solidFill>
@@ -12615,7 +12615,7 @@
                           <a:cs typeface="Ubuntu Mono"/>
                           <a:sym typeface="Ubuntu Mono"/>
                         </a:rPr>
-                        <a:t>17-1/2 / 22-5/8</a:t>
+                        <a:t>17-1/2, 22-5/8</a:t>
                       </a:r>
                     </a:p>
                   </a:txBody>
@@ -12656,11 +12656,11 @@
                     <a:p>
                       <a:pPr algn="ctr">
                         <a:lnSpc>
-                          <a:spcPts val="740"/>
-                        </a:lnSpc>
-                      </a:pPr>
-                      <a:r>
-                        <a:rPr sz="580" b="0">
+                          <a:spcPts val="719"/>
+                        </a:lnSpc>
+                      </a:pPr>
+                      <a:r>
+                        <a:rPr sz="560" b="0">
                           <a:solidFill>
                             <a:srgbClr val="000000"/>
                           </a:solidFill>
@@ -12710,11 +12710,11 @@
                     <a:p>
                       <a:pPr algn="ctr">
                         <a:lnSpc>
-                          <a:spcPts val="740"/>
-                        </a:lnSpc>
-                      </a:pPr>
-                      <a:r>
-                        <a:rPr sz="580" b="0">
+                          <a:spcPts val="719"/>
+                        </a:lnSpc>
+                      </a:pPr>
+                      <a:r>
+                        <a:rPr sz="560" b="0">
                           <a:solidFill>
                             <a:srgbClr val="000000"/>
                           </a:solidFill>
@@ -12764,11 +12764,11 @@
                     <a:p>
                       <a:pPr algn="ctr">
                         <a:lnSpc>
-                          <a:spcPts val="740"/>
-                        </a:lnSpc>
-                      </a:pPr>
-                      <a:r>
-                        <a:rPr sz="580" b="0">
+                          <a:spcPts val="719"/>
+                        </a:lnSpc>
+                      </a:pPr>
+                      <a:r>
+                        <a:rPr sz="560" b="0">
                           <a:solidFill>
                             <a:srgbClr val="000000"/>
                           </a:solidFill>
@@ -12820,11 +12820,11 @@
                     <a:p>
                       <a:pPr algn="ctr">
                         <a:lnSpc>
-                          <a:spcPts val="740"/>
-                        </a:lnSpc>
-                      </a:pPr>
-                      <a:r>
-                        <a:rPr sz="580" b="0">
+                          <a:spcPts val="719"/>
+                        </a:lnSpc>
+                      </a:pPr>
+                      <a:r>
+                        <a:rPr sz="560" b="0">
                           <a:solidFill>
                             <a:srgbClr val="FEFEFF"/>
                           </a:solidFill>
@@ -12874,11 +12874,11 @@
                     <a:p>
                       <a:pPr algn="ctr">
                         <a:lnSpc>
-                          <a:spcPts val="740"/>
-                        </a:lnSpc>
-                      </a:pPr>
-                      <a:r>
-                        <a:rPr sz="580" b="0">
+                          <a:spcPts val="719"/>
+                        </a:lnSpc>
+                      </a:pPr>
+                      <a:r>
+                        <a:rPr sz="560" b="0">
                           <a:solidFill>
                             <a:srgbClr val="000000"/>
                           </a:solidFill>
@@ -12887,7 +12887,7 @@
                           <a:cs typeface="Ubuntu Mono"/>
                           <a:sym typeface="Ubuntu Mono"/>
                         </a:rPr>
-                        <a:t>17-1/2 / 26-5/8 / 36-5/8</a:t>
+                        <a:t>17-1/2, 26-5/8, 36-5/8</a:t>
                       </a:r>
                     </a:p>
                   </a:txBody>
@@ -12928,11 +12928,11 @@
                     <a:p>
                       <a:pPr algn="ctr">
                         <a:lnSpc>
-                          <a:spcPts val="740"/>
-                        </a:lnSpc>
-                      </a:pPr>
-                      <a:r>
-                        <a:rPr sz="580" b="0">
+                          <a:spcPts val="719"/>
+                        </a:lnSpc>
+                      </a:pPr>
+                      <a:r>
+                        <a:rPr sz="560" b="0">
                           <a:solidFill>
                             <a:srgbClr val="000000"/>
                           </a:solidFill>
@@ -12941,7 +12941,7 @@
                           <a:cs typeface="Ubuntu Mono"/>
                           <a:sym typeface="Ubuntu Mono"/>
                         </a:rPr>
-                        <a:t>9-1/2 / 12-1/4 / 24-5/8</a:t>
+                        <a:t>9-1/2, 12-1/4, 24-5/8</a:t>
                       </a:r>
                     </a:p>
                   </a:txBody>
@@ -12982,11 +12982,11 @@
                     <a:p>
                       <a:pPr algn="ctr">
                         <a:lnSpc>
-                          <a:spcPts val="740"/>
-                        </a:lnSpc>
-                      </a:pPr>
-                      <a:r>
-                        <a:rPr sz="580" b="0">
+                          <a:spcPts val="719"/>
+                        </a:lnSpc>
+                      </a:pPr>
+                      <a:r>
+                        <a:rPr sz="560" b="0">
                           <a:solidFill>
                             <a:srgbClr val="000000"/>
                           </a:solidFill>
@@ -13036,11 +13036,11 @@
                     <a:p>
                       <a:pPr algn="ctr">
                         <a:lnSpc>
-                          <a:spcPts val="740"/>
-                        </a:lnSpc>
-                      </a:pPr>
-                      <a:r>
-                        <a:rPr sz="580" b="0">
+                          <a:spcPts val="719"/>
+                        </a:lnSpc>
+                      </a:pPr>
+                      <a:r>
+                        <a:rPr sz="560" b="0">
                           <a:solidFill>
                             <a:srgbClr val="000000"/>
                           </a:solidFill>
@@ -13096,8 +13096,8 @@
         </p:nvSpPr>
         <p:spPr>
           <a:xfrm>
-            <a:off x="4089400" y="10604500"/>
-            <a:ext cx="2755900" cy="177800"/>
+            <a:off x="2260600" y="10007600"/>
+            <a:ext cx="1778000" cy="177800"/>
           </a:xfrm>
           <a:prstGeom prst="rect">
             <a:avLst/>
@@ -13138,8 +13138,8 @@
         </p:nvSpPr>
         <p:spPr>
           <a:xfrm>
-            <a:off x="4089400" y="10782300"/>
-            <a:ext cx="2755900" cy="508000"/>
+            <a:off x="2260600" y="10185400"/>
+            <a:ext cx="1778000" cy="762000"/>
           </a:xfrm>
           <a:prstGeom prst="rect">
             <a:avLst/>

</xml_diff>

<commit_message>
Fiches outils: Hole Opener, 27 fiches, catalogue PDF et zip mis à jour
Co-Authored-By: Claude Sonnet 5.5 <noreply@anthropic.com>
Claude-Session: https://claude.ai/code/session_01XPwnZBmWUGhvYebrP3X3Z2
</commit_message>
<xml_diff>
--- a/fiches_outils/Fiche_technique_HoleOpener.pptx
+++ b/fiches_outils/Fiche_technique_HoleOpener.pptx
@@ -10854,7 +10854,7 @@
         </p:nvSpPr>
         <p:spPr>
           <a:xfrm>
-            <a:off x="4089400" y="8102600"/>
+            <a:off x="4089400" y="8051800"/>
             <a:ext cx="2755900" cy="177800"/>
           </a:xfrm>
           <a:prstGeom prst="rect">
@@ -10897,7 +10897,7 @@
           <p:nvPr/>
         </p:nvGraphicFramePr>
         <p:xfrm>
-          <a:off x="4089400" y="8293100"/>
+          <a:off x="4089400" y="8242300"/>
           <a:ext cx="2755900" cy="558800"/>
         </p:xfrm>
         <a:graphic>
@@ -11577,7 +11577,7 @@
         </p:nvSpPr>
         <p:spPr>
           <a:xfrm>
-            <a:off x="4089400" y="8877300"/>
+            <a:off x="4089400" y="8826500"/>
             <a:ext cx="2755900" cy="114300"/>
           </a:xfrm>
           <a:prstGeom prst="rect">
@@ -11622,7 +11622,7 @@
         </p:nvSpPr>
         <p:spPr>
           <a:xfrm>
-            <a:off x="4089400" y="9017000"/>
+            <a:off x="4089400" y="8928100"/>
             <a:ext cx="2755900" cy="177800"/>
           </a:xfrm>
           <a:prstGeom prst="rect">
@@ -11664,8 +11664,8 @@
         </p:nvSpPr>
         <p:spPr>
           <a:xfrm>
-            <a:off x="4089400" y="9207500"/>
-            <a:ext cx="2755900" cy="508000"/>
+            <a:off x="4089400" y="9118600"/>
+            <a:ext cx="2755900" cy="762000"/>
           </a:xfrm>
           <a:prstGeom prst="rect">
             <a:avLst/>
@@ -11696,1408 +11696,21 @@
                 <a:cs typeface="Ubuntu Mono"/>
                 <a:sym typeface="Ubuntu Mono"/>
               </a:rPr>
-              <a:t>Cone-arm hole opener, up to 36 in.; one body takes several arm sizes. Bottom box for bit or bullnose. Milled tooth, TCI or PDC cones; soft to medium-hard formations.</a:t>
+              <a:t>Cone-arm hole opener, up to 36 in.; one body takes several arm sizes. Bottom box for bit or bullnose. Milled tooth, TCI or PDC cones; soft to medium-hard formations. Body series 8200 to 15000: std. opening 12-1/4 to 36-5/8 in., min. pilot hole 8-1/2 to 24-5/8 in., body Ø 8-1/4 to 15-5/8 in., 640 - 1,900 lb.</a:t>
             </a:r>
           </a:p>
         </p:txBody>
       </p:sp>
-      <p:graphicFrame>
-        <p:nvGraphicFramePr>
-          <p:cNvPr id="37" name="Table 36"/>
-          <p:cNvGraphicFramePr>
-            <a:graphicFrameLocks noGrp="1"/>
-          </p:cNvGraphicFramePr>
-          <p:nvPr/>
-        </p:nvGraphicFramePr>
-        <p:xfrm>
-          <a:off x="4089400" y="9537700"/>
-          <a:ext cx="2755900" cy="698500"/>
-        </p:xfrm>
-        <a:graphic>
-          <a:graphicData uri="http://schemas.openxmlformats.org/drawingml/2006/table">
-            <a:tbl>
-              <a:tblPr/>
-              <a:tblGrid>
-                <a:gridCol w="381000"/>
-                <a:gridCol w="838200"/>
-                <a:gridCol w="812800"/>
-                <a:gridCol w="381000"/>
-                <a:gridCol w="342900"/>
-              </a:tblGrid>
-              <a:tr h="139700">
-                <a:tc>
-                  <a:txBody>
-                    <a:bodyPr wrap="square"/>
-                    <a:lstStyle/>
-                    <a:p>
-                      <a:pPr algn="ctr">
-                        <a:lnSpc>
-                          <a:spcPts val="719"/>
-                        </a:lnSpc>
-                      </a:pPr>
-                      <a:r>
-                        <a:rPr sz="560" b="1">
-                          <a:solidFill>
-                            <a:srgbClr val="FEFEFF"/>
-                          </a:solidFill>
-                          <a:latin typeface="Ubuntu Mono"/>
-                          <a:ea typeface="Ubuntu Mono"/>
-                          <a:cs typeface="Ubuntu Mono"/>
-                          <a:sym typeface="Ubuntu Mono"/>
-                        </a:rPr>
-                        <a:t>Series</a:t>
-                      </a:r>
-                    </a:p>
-                  </a:txBody>
-                  <a:tcPr marL="27940" marR="27940" marT="15240" marB="15240" anchor="ctr">
-                    <a:lnL w="4762" cap="flat" cmpd="sng" algn="ctr">
-                      <a:solidFill>
-                        <a:srgbClr val="000000"/>
-                      </a:solidFill>
-                      <a:prstDash val="solid"/>
-                    </a:lnL>
-                    <a:lnR w="4762" cap="flat" cmpd="sng" algn="ctr">
-                      <a:solidFill>
-                        <a:srgbClr val="000000"/>
-                      </a:solidFill>
-                      <a:prstDash val="solid"/>
-                    </a:lnR>
-                    <a:lnT w="4762" cap="flat" cmpd="sng" algn="ctr">
-                      <a:solidFill>
-                        <a:srgbClr val="000000"/>
-                      </a:solidFill>
-                      <a:prstDash val="solid"/>
-                    </a:lnT>
-                    <a:lnB w="4762" cap="flat" cmpd="sng" algn="ctr">
-                      <a:solidFill>
-                        <a:srgbClr val="000000"/>
-                      </a:solidFill>
-                      <a:prstDash val="solid"/>
-                    </a:lnB>
-                    <a:solidFill>
-                      <a:srgbClr val="194E9A"/>
-                    </a:solidFill>
-                  </a:tcPr>
-                </a:tc>
-                <a:tc>
-                  <a:txBody>
-                    <a:bodyPr wrap="square"/>
-                    <a:lstStyle/>
-                    <a:p>
-                      <a:pPr algn="ctr">
-                        <a:lnSpc>
-                          <a:spcPts val="719"/>
-                        </a:lnSpc>
-                      </a:pPr>
-                      <a:r>
-                        <a:rPr sz="560" b="1">
-                          <a:solidFill>
-                            <a:srgbClr val="FEFEFF"/>
-                          </a:solidFill>
-                          <a:latin typeface="Ubuntu Mono"/>
-                          <a:ea typeface="Ubuntu Mono"/>
-                          <a:cs typeface="Ubuntu Mono"/>
-                          <a:sym typeface="Ubuntu Mono"/>
-                        </a:rPr>
-                        <a:t>Std. opening Ø</a:t>
-                      </a:r>
-                    </a:p>
-                  </a:txBody>
-                  <a:tcPr marL="27940" marR="27940" marT="15240" marB="15240" anchor="ctr">
-                    <a:lnL w="4762" cap="flat" cmpd="sng" algn="ctr">
-                      <a:solidFill>
-                        <a:srgbClr val="000000"/>
-                      </a:solidFill>
-                      <a:prstDash val="solid"/>
-                    </a:lnL>
-                    <a:lnR w="4762" cap="flat" cmpd="sng" algn="ctr">
-                      <a:solidFill>
-                        <a:srgbClr val="000000"/>
-                      </a:solidFill>
-                      <a:prstDash val="solid"/>
-                    </a:lnR>
-                    <a:lnT w="4762" cap="flat" cmpd="sng" algn="ctr">
-                      <a:solidFill>
-                        <a:srgbClr val="000000"/>
-                      </a:solidFill>
-                      <a:prstDash val="solid"/>
-                    </a:lnT>
-                    <a:lnB w="4762" cap="flat" cmpd="sng" algn="ctr">
-                      <a:solidFill>
-                        <a:srgbClr val="000000"/>
-                      </a:solidFill>
-                      <a:prstDash val="solid"/>
-                    </a:lnB>
-                    <a:solidFill>
-                      <a:srgbClr val="194E9A"/>
-                    </a:solidFill>
-                  </a:tcPr>
-                </a:tc>
-                <a:tc>
-                  <a:txBody>
-                    <a:bodyPr wrap="square"/>
-                    <a:lstStyle/>
-                    <a:p>
-                      <a:pPr algn="ctr">
-                        <a:lnSpc>
-                          <a:spcPts val="719"/>
-                        </a:lnSpc>
-                      </a:pPr>
-                      <a:r>
-                        <a:rPr sz="560" b="1">
-                          <a:solidFill>
-                            <a:srgbClr val="FEFEFF"/>
-                          </a:solidFill>
-                          <a:latin typeface="Ubuntu Mono"/>
-                          <a:ea typeface="Ubuntu Mono"/>
-                          <a:cs typeface="Ubuntu Mono"/>
-                          <a:sym typeface="Ubuntu Mono"/>
-                        </a:rPr>
-                        <a:t>Min. pilot Ø</a:t>
-                      </a:r>
-                    </a:p>
-                  </a:txBody>
-                  <a:tcPr marL="27940" marR="27940" marT="15240" marB="15240" anchor="ctr">
-                    <a:lnL w="4762" cap="flat" cmpd="sng" algn="ctr">
-                      <a:solidFill>
-                        <a:srgbClr val="000000"/>
-                      </a:solidFill>
-                      <a:prstDash val="solid"/>
-                    </a:lnL>
-                    <a:lnR w="4762" cap="flat" cmpd="sng" algn="ctr">
-                      <a:solidFill>
-                        <a:srgbClr val="000000"/>
-                      </a:solidFill>
-                      <a:prstDash val="solid"/>
-                    </a:lnR>
-                    <a:lnT w="4762" cap="flat" cmpd="sng" algn="ctr">
-                      <a:solidFill>
-                        <a:srgbClr val="000000"/>
-                      </a:solidFill>
-                      <a:prstDash val="solid"/>
-                    </a:lnT>
-                    <a:lnB w="4762" cap="flat" cmpd="sng" algn="ctr">
-                      <a:solidFill>
-                        <a:srgbClr val="000000"/>
-                      </a:solidFill>
-                      <a:prstDash val="solid"/>
-                    </a:lnB>
-                    <a:solidFill>
-                      <a:srgbClr val="194E9A"/>
-                    </a:solidFill>
-                  </a:tcPr>
-                </a:tc>
-                <a:tc>
-                  <a:txBody>
-                    <a:bodyPr wrap="square"/>
-                    <a:lstStyle/>
-                    <a:p>
-                      <a:pPr algn="ctr">
-                        <a:lnSpc>
-                          <a:spcPts val="719"/>
-                        </a:lnSpc>
-                      </a:pPr>
-                      <a:r>
-                        <a:rPr sz="560" b="1">
-                          <a:solidFill>
-                            <a:srgbClr val="FEFEFF"/>
-                          </a:solidFill>
-                          <a:latin typeface="Ubuntu Mono"/>
-                          <a:ea typeface="Ubuntu Mono"/>
-                          <a:cs typeface="Ubuntu Mono"/>
-                          <a:sym typeface="Ubuntu Mono"/>
-                        </a:rPr>
-                        <a:t>Body Ø</a:t>
-                      </a:r>
-                    </a:p>
-                  </a:txBody>
-                  <a:tcPr marL="27940" marR="27940" marT="15240" marB="15240" anchor="ctr">
-                    <a:lnL w="4762" cap="flat" cmpd="sng" algn="ctr">
-                      <a:solidFill>
-                        <a:srgbClr val="000000"/>
-                      </a:solidFill>
-                      <a:prstDash val="solid"/>
-                    </a:lnL>
-                    <a:lnR w="4762" cap="flat" cmpd="sng" algn="ctr">
-                      <a:solidFill>
-                        <a:srgbClr val="000000"/>
-                      </a:solidFill>
-                      <a:prstDash val="solid"/>
-                    </a:lnR>
-                    <a:lnT w="4762" cap="flat" cmpd="sng" algn="ctr">
-                      <a:solidFill>
-                        <a:srgbClr val="000000"/>
-                      </a:solidFill>
-                      <a:prstDash val="solid"/>
-                    </a:lnT>
-                    <a:lnB w="4762" cap="flat" cmpd="sng" algn="ctr">
-                      <a:solidFill>
-                        <a:srgbClr val="000000"/>
-                      </a:solidFill>
-                      <a:prstDash val="solid"/>
-                    </a:lnB>
-                    <a:solidFill>
-                      <a:srgbClr val="194E9A"/>
-                    </a:solidFill>
-                  </a:tcPr>
-                </a:tc>
-                <a:tc>
-                  <a:txBody>
-                    <a:bodyPr wrap="square"/>
-                    <a:lstStyle/>
-                    <a:p>
-                      <a:pPr algn="ctr">
-                        <a:lnSpc>
-                          <a:spcPts val="719"/>
-                        </a:lnSpc>
-                      </a:pPr>
-                      <a:r>
-                        <a:rPr sz="560" b="1">
-                          <a:solidFill>
-                            <a:srgbClr val="FEFEFF"/>
-                          </a:solidFill>
-                          <a:latin typeface="Ubuntu Mono"/>
-                          <a:ea typeface="Ubuntu Mono"/>
-                          <a:cs typeface="Ubuntu Mono"/>
-                          <a:sym typeface="Ubuntu Mono"/>
-                        </a:rPr>
-                        <a:t>Wt (lb)</a:t>
-                      </a:r>
-                    </a:p>
-                  </a:txBody>
-                  <a:tcPr marL="27940" marR="27940" marT="15240" marB="15240" anchor="ctr">
-                    <a:lnL w="4762" cap="flat" cmpd="sng" algn="ctr">
-                      <a:solidFill>
-                        <a:srgbClr val="000000"/>
-                      </a:solidFill>
-                      <a:prstDash val="solid"/>
-                    </a:lnL>
-                    <a:lnR w="4762" cap="flat" cmpd="sng" algn="ctr">
-                      <a:solidFill>
-                        <a:srgbClr val="000000"/>
-                      </a:solidFill>
-                      <a:prstDash val="solid"/>
-                    </a:lnR>
-                    <a:lnT w="4762" cap="flat" cmpd="sng" algn="ctr">
-                      <a:solidFill>
-                        <a:srgbClr val="000000"/>
-                      </a:solidFill>
-                      <a:prstDash val="solid"/>
-                    </a:lnT>
-                    <a:lnB w="4762" cap="flat" cmpd="sng" algn="ctr">
-                      <a:solidFill>
-                        <a:srgbClr val="000000"/>
-                      </a:solidFill>
-                      <a:prstDash val="solid"/>
-                    </a:lnB>
-                    <a:solidFill>
-                      <a:srgbClr val="194E9A"/>
-                    </a:solidFill>
-                  </a:tcPr>
-                </a:tc>
-              </a:tr>
-              <a:tr h="139700">
-                <a:tc>
-                  <a:txBody>
-                    <a:bodyPr wrap="square"/>
-                    <a:lstStyle/>
-                    <a:p>
-                      <a:pPr algn="ctr">
-                        <a:lnSpc>
-                          <a:spcPts val="719"/>
-                        </a:lnSpc>
-                      </a:pPr>
-                      <a:r>
-                        <a:rPr sz="560" b="0">
-                          <a:solidFill>
-                            <a:srgbClr val="FEFEFF"/>
-                          </a:solidFill>
-                          <a:latin typeface="Ubuntu Mono"/>
-                          <a:ea typeface="Ubuntu Mono"/>
-                          <a:cs typeface="Ubuntu Mono"/>
-                          <a:sym typeface="Ubuntu Mono"/>
-                        </a:rPr>
-                        <a:t>8200</a:t>
-                      </a:r>
-                    </a:p>
-                  </a:txBody>
-                  <a:tcPr marL="27940" marR="27940" marT="15240" marB="15240" anchor="ctr">
-                    <a:lnL w="4762" cap="flat" cmpd="sng" algn="ctr">
-                      <a:solidFill>
-                        <a:srgbClr val="000000"/>
-                      </a:solidFill>
-                      <a:prstDash val="solid"/>
-                    </a:lnL>
-                    <a:lnR w="4762" cap="flat" cmpd="sng" algn="ctr">
-                      <a:solidFill>
-                        <a:srgbClr val="000000"/>
-                      </a:solidFill>
-                      <a:prstDash val="solid"/>
-                    </a:lnR>
-                    <a:lnT w="4762" cap="flat" cmpd="sng" algn="ctr">
-                      <a:solidFill>
-                        <a:srgbClr val="000000"/>
-                      </a:solidFill>
-                      <a:prstDash val="solid"/>
-                    </a:lnT>
-                    <a:lnB w="4762" cap="flat" cmpd="sng" algn="ctr">
-                      <a:solidFill>
-                        <a:srgbClr val="000000"/>
-                      </a:solidFill>
-                      <a:prstDash val="solid"/>
-                    </a:lnB>
-                    <a:solidFill>
-                      <a:srgbClr val="194E9A"/>
-                    </a:solidFill>
-                  </a:tcPr>
-                </a:tc>
-                <a:tc>
-                  <a:txBody>
-                    <a:bodyPr wrap="square"/>
-                    <a:lstStyle/>
-                    <a:p>
-                      <a:pPr algn="ctr">
-                        <a:lnSpc>
-                          <a:spcPts val="719"/>
-                        </a:lnSpc>
-                      </a:pPr>
-                      <a:r>
-                        <a:rPr sz="560" b="0">
-                          <a:solidFill>
-                            <a:srgbClr val="000000"/>
-                          </a:solidFill>
-                          <a:latin typeface="Ubuntu Mono"/>
-                          <a:ea typeface="Ubuntu Mono"/>
-                          <a:cs typeface="Ubuntu Mono"/>
-                          <a:sym typeface="Ubuntu Mono"/>
-                        </a:rPr>
-                        <a:t>12-1/4</a:t>
-                      </a:r>
-                    </a:p>
-                  </a:txBody>
-                  <a:tcPr marL="27940" marR="27940" marT="15240" marB="15240" anchor="ctr">
-                    <a:lnL w="4762" cap="flat" cmpd="sng" algn="ctr">
-                      <a:solidFill>
-                        <a:srgbClr val="000000"/>
-                      </a:solidFill>
-                      <a:prstDash val="solid"/>
-                    </a:lnL>
-                    <a:lnR w="4762" cap="flat" cmpd="sng" algn="ctr">
-                      <a:solidFill>
-                        <a:srgbClr val="000000"/>
-                      </a:solidFill>
-                      <a:prstDash val="solid"/>
-                    </a:lnR>
-                    <a:lnT w="4762" cap="flat" cmpd="sng" algn="ctr">
-                      <a:solidFill>
-                        <a:srgbClr val="000000"/>
-                      </a:solidFill>
-                      <a:prstDash val="solid"/>
-                    </a:lnT>
-                    <a:lnB w="4762" cap="flat" cmpd="sng" algn="ctr">
-                      <a:solidFill>
-                        <a:srgbClr val="000000"/>
-                      </a:solidFill>
-                      <a:prstDash val="solid"/>
-                    </a:lnB>
-                    <a:solidFill>
-                      <a:srgbClr val="FFFFFF"/>
-                    </a:solidFill>
-                  </a:tcPr>
-                </a:tc>
-                <a:tc>
-                  <a:txBody>
-                    <a:bodyPr wrap="square"/>
-                    <a:lstStyle/>
-                    <a:p>
-                      <a:pPr algn="ctr">
-                        <a:lnSpc>
-                          <a:spcPts val="719"/>
-                        </a:lnSpc>
-                      </a:pPr>
-                      <a:r>
-                        <a:rPr sz="560" b="0">
-                          <a:solidFill>
-                            <a:srgbClr val="000000"/>
-                          </a:solidFill>
-                          <a:latin typeface="Ubuntu Mono"/>
-                          <a:ea typeface="Ubuntu Mono"/>
-                          <a:cs typeface="Ubuntu Mono"/>
-                          <a:sym typeface="Ubuntu Mono"/>
-                        </a:rPr>
-                        <a:t>8-1/2</a:t>
-                      </a:r>
-                    </a:p>
-                  </a:txBody>
-                  <a:tcPr marL="27940" marR="27940" marT="15240" marB="15240" anchor="ctr">
-                    <a:lnL w="4762" cap="flat" cmpd="sng" algn="ctr">
-                      <a:solidFill>
-                        <a:srgbClr val="000000"/>
-                      </a:solidFill>
-                      <a:prstDash val="solid"/>
-                    </a:lnL>
-                    <a:lnR w="4762" cap="flat" cmpd="sng" algn="ctr">
-                      <a:solidFill>
-                        <a:srgbClr val="000000"/>
-                      </a:solidFill>
-                      <a:prstDash val="solid"/>
-                    </a:lnR>
-                    <a:lnT w="4762" cap="flat" cmpd="sng" algn="ctr">
-                      <a:solidFill>
-                        <a:srgbClr val="000000"/>
-                      </a:solidFill>
-                      <a:prstDash val="solid"/>
-                    </a:lnT>
-                    <a:lnB w="4762" cap="flat" cmpd="sng" algn="ctr">
-                      <a:solidFill>
-                        <a:srgbClr val="000000"/>
-                      </a:solidFill>
-                      <a:prstDash val="solid"/>
-                    </a:lnB>
-                    <a:solidFill>
-                      <a:srgbClr val="FFFFFF"/>
-                    </a:solidFill>
-                  </a:tcPr>
-                </a:tc>
-                <a:tc>
-                  <a:txBody>
-                    <a:bodyPr wrap="square"/>
-                    <a:lstStyle/>
-                    <a:p>
-                      <a:pPr algn="ctr">
-                        <a:lnSpc>
-                          <a:spcPts val="719"/>
-                        </a:lnSpc>
-                      </a:pPr>
-                      <a:r>
-                        <a:rPr sz="560" b="0">
-                          <a:solidFill>
-                            <a:srgbClr val="000000"/>
-                          </a:solidFill>
-                          <a:latin typeface="Ubuntu Mono"/>
-                          <a:ea typeface="Ubuntu Mono"/>
-                          <a:cs typeface="Ubuntu Mono"/>
-                          <a:sym typeface="Ubuntu Mono"/>
-                        </a:rPr>
-                        <a:t>8-1/4</a:t>
-                      </a:r>
-                    </a:p>
-                  </a:txBody>
-                  <a:tcPr marL="27940" marR="27940" marT="15240" marB="15240" anchor="ctr">
-                    <a:lnL w="4762" cap="flat" cmpd="sng" algn="ctr">
-                      <a:solidFill>
-                        <a:srgbClr val="000000"/>
-                      </a:solidFill>
-                      <a:prstDash val="solid"/>
-                    </a:lnL>
-                    <a:lnR w="4762" cap="flat" cmpd="sng" algn="ctr">
-                      <a:solidFill>
-                        <a:srgbClr val="000000"/>
-                      </a:solidFill>
-                      <a:prstDash val="solid"/>
-                    </a:lnR>
-                    <a:lnT w="4762" cap="flat" cmpd="sng" algn="ctr">
-                      <a:solidFill>
-                        <a:srgbClr val="000000"/>
-                      </a:solidFill>
-                      <a:prstDash val="solid"/>
-                    </a:lnT>
-                    <a:lnB w="4762" cap="flat" cmpd="sng" algn="ctr">
-                      <a:solidFill>
-                        <a:srgbClr val="000000"/>
-                      </a:solidFill>
-                      <a:prstDash val="solid"/>
-                    </a:lnB>
-                    <a:solidFill>
-                      <a:srgbClr val="FFFFFF"/>
-                    </a:solidFill>
-                  </a:tcPr>
-                </a:tc>
-                <a:tc>
-                  <a:txBody>
-                    <a:bodyPr wrap="square"/>
-                    <a:lstStyle/>
-                    <a:p>
-                      <a:pPr algn="ctr">
-                        <a:lnSpc>
-                          <a:spcPts val="719"/>
-                        </a:lnSpc>
-                      </a:pPr>
-                      <a:r>
-                        <a:rPr sz="560" b="0">
-                          <a:solidFill>
-                            <a:srgbClr val="000000"/>
-                          </a:solidFill>
-                          <a:latin typeface="Ubuntu Mono"/>
-                          <a:ea typeface="Ubuntu Mono"/>
-                          <a:cs typeface="Ubuntu Mono"/>
-                          <a:sym typeface="Ubuntu Mono"/>
-                        </a:rPr>
-                        <a:t>640</a:t>
-                      </a:r>
-                    </a:p>
-                  </a:txBody>
-                  <a:tcPr marL="27940" marR="27940" marT="15240" marB="15240" anchor="ctr">
-                    <a:lnL w="4762" cap="flat" cmpd="sng" algn="ctr">
-                      <a:solidFill>
-                        <a:srgbClr val="000000"/>
-                      </a:solidFill>
-                      <a:prstDash val="solid"/>
-                    </a:lnL>
-                    <a:lnR w="4762" cap="flat" cmpd="sng" algn="ctr">
-                      <a:solidFill>
-                        <a:srgbClr val="000000"/>
-                      </a:solidFill>
-                      <a:prstDash val="solid"/>
-                    </a:lnR>
-                    <a:lnT w="4762" cap="flat" cmpd="sng" algn="ctr">
-                      <a:solidFill>
-                        <a:srgbClr val="000000"/>
-                      </a:solidFill>
-                      <a:prstDash val="solid"/>
-                    </a:lnT>
-                    <a:lnB w="4762" cap="flat" cmpd="sng" algn="ctr">
-                      <a:solidFill>
-                        <a:srgbClr val="000000"/>
-                      </a:solidFill>
-                      <a:prstDash val="solid"/>
-                    </a:lnB>
-                    <a:solidFill>
-                      <a:srgbClr val="FFFFFF"/>
-                    </a:solidFill>
-                  </a:tcPr>
-                </a:tc>
-              </a:tr>
-              <a:tr h="139700">
-                <a:tc>
-                  <a:txBody>
-                    <a:bodyPr wrap="square"/>
-                    <a:lstStyle/>
-                    <a:p>
-                      <a:pPr algn="ctr">
-                        <a:lnSpc>
-                          <a:spcPts val="719"/>
-                        </a:lnSpc>
-                      </a:pPr>
-                      <a:r>
-                        <a:rPr sz="560" b="0">
-                          <a:solidFill>
-                            <a:srgbClr val="FEFEFF"/>
-                          </a:solidFill>
-                          <a:latin typeface="Ubuntu Mono"/>
-                          <a:ea typeface="Ubuntu Mono"/>
-                          <a:cs typeface="Ubuntu Mono"/>
-                          <a:sym typeface="Ubuntu Mono"/>
-                        </a:rPr>
-                        <a:t>9500</a:t>
-                      </a:r>
-                    </a:p>
-                  </a:txBody>
-                  <a:tcPr marL="27940" marR="27940" marT="15240" marB="15240" anchor="ctr">
-                    <a:lnL w="4762" cap="flat" cmpd="sng" algn="ctr">
-                      <a:solidFill>
-                        <a:srgbClr val="000000"/>
-                      </a:solidFill>
-                      <a:prstDash val="solid"/>
-                    </a:lnL>
-                    <a:lnR w="4762" cap="flat" cmpd="sng" algn="ctr">
-                      <a:solidFill>
-                        <a:srgbClr val="000000"/>
-                      </a:solidFill>
-                      <a:prstDash val="solid"/>
-                    </a:lnR>
-                    <a:lnT w="4762" cap="flat" cmpd="sng" algn="ctr">
-                      <a:solidFill>
-                        <a:srgbClr val="000000"/>
-                      </a:solidFill>
-                      <a:prstDash val="solid"/>
-                    </a:lnT>
-                    <a:lnB w="4762" cap="flat" cmpd="sng" algn="ctr">
-                      <a:solidFill>
-                        <a:srgbClr val="000000"/>
-                      </a:solidFill>
-                      <a:prstDash val="solid"/>
-                    </a:lnB>
-                    <a:solidFill>
-                      <a:srgbClr val="01ADEE"/>
-                    </a:solidFill>
-                  </a:tcPr>
-                </a:tc>
-                <a:tc>
-                  <a:txBody>
-                    <a:bodyPr wrap="square"/>
-                    <a:lstStyle/>
-                    <a:p>
-                      <a:pPr algn="ctr">
-                        <a:lnSpc>
-                          <a:spcPts val="719"/>
-                        </a:lnSpc>
-                      </a:pPr>
-                      <a:r>
-                        <a:rPr sz="560" b="0">
-                          <a:solidFill>
-                            <a:srgbClr val="000000"/>
-                          </a:solidFill>
-                          <a:latin typeface="Ubuntu Mono"/>
-                          <a:ea typeface="Ubuntu Mono"/>
-                          <a:cs typeface="Ubuntu Mono"/>
-                          <a:sym typeface="Ubuntu Mono"/>
-                        </a:rPr>
-                        <a:t>12-1/4, 14-3/4</a:t>
-                      </a:r>
-                    </a:p>
-                  </a:txBody>
-                  <a:tcPr marL="27940" marR="27940" marT="15240" marB="15240" anchor="ctr">
-                    <a:lnL w="4762" cap="flat" cmpd="sng" algn="ctr">
-                      <a:solidFill>
-                        <a:srgbClr val="000000"/>
-                      </a:solidFill>
-                      <a:prstDash val="solid"/>
-                    </a:lnL>
-                    <a:lnR w="4762" cap="flat" cmpd="sng" algn="ctr">
-                      <a:solidFill>
-                        <a:srgbClr val="000000"/>
-                      </a:solidFill>
-                      <a:prstDash val="solid"/>
-                    </a:lnR>
-                    <a:lnT w="4762" cap="flat" cmpd="sng" algn="ctr">
-                      <a:solidFill>
-                        <a:srgbClr val="000000"/>
-                      </a:solidFill>
-                      <a:prstDash val="solid"/>
-                    </a:lnT>
-                    <a:lnB w="4762" cap="flat" cmpd="sng" algn="ctr">
-                      <a:solidFill>
-                        <a:srgbClr val="000000"/>
-                      </a:solidFill>
-                      <a:prstDash val="solid"/>
-                    </a:lnB>
-                    <a:solidFill>
-                      <a:srgbClr val="EEF6FD"/>
-                    </a:solidFill>
-                  </a:tcPr>
-                </a:tc>
-                <a:tc>
-                  <a:txBody>
-                    <a:bodyPr wrap="square"/>
-                    <a:lstStyle/>
-                    <a:p>
-                      <a:pPr algn="ctr">
-                        <a:lnSpc>
-                          <a:spcPts val="719"/>
-                        </a:lnSpc>
-                      </a:pPr>
-                      <a:r>
-                        <a:rPr sz="560" b="0">
-                          <a:solidFill>
-                            <a:srgbClr val="000000"/>
-                          </a:solidFill>
-                          <a:latin typeface="Ubuntu Mono"/>
-                          <a:ea typeface="Ubuntu Mono"/>
-                          <a:cs typeface="Ubuntu Mono"/>
-                          <a:sym typeface="Ubuntu Mono"/>
-                        </a:rPr>
-                        <a:t>8-1/2, 9-1/2</a:t>
-                      </a:r>
-                    </a:p>
-                  </a:txBody>
-                  <a:tcPr marL="27940" marR="27940" marT="15240" marB="15240" anchor="ctr">
-                    <a:lnL w="4762" cap="flat" cmpd="sng" algn="ctr">
-                      <a:solidFill>
-                        <a:srgbClr val="000000"/>
-                      </a:solidFill>
-                      <a:prstDash val="solid"/>
-                    </a:lnL>
-                    <a:lnR w="4762" cap="flat" cmpd="sng" algn="ctr">
-                      <a:solidFill>
-                        <a:srgbClr val="000000"/>
-                      </a:solidFill>
-                      <a:prstDash val="solid"/>
-                    </a:lnR>
-                    <a:lnT w="4762" cap="flat" cmpd="sng" algn="ctr">
-                      <a:solidFill>
-                        <a:srgbClr val="000000"/>
-                      </a:solidFill>
-                      <a:prstDash val="solid"/>
-                    </a:lnT>
-                    <a:lnB w="4762" cap="flat" cmpd="sng" algn="ctr">
-                      <a:solidFill>
-                        <a:srgbClr val="000000"/>
-                      </a:solidFill>
-                      <a:prstDash val="solid"/>
-                    </a:lnB>
-                    <a:solidFill>
-                      <a:srgbClr val="EEF6FD"/>
-                    </a:solidFill>
-                  </a:tcPr>
-                </a:tc>
-                <a:tc>
-                  <a:txBody>
-                    <a:bodyPr wrap="square"/>
-                    <a:lstStyle/>
-                    <a:p>
-                      <a:pPr algn="ctr">
-                        <a:lnSpc>
-                          <a:spcPts val="719"/>
-                        </a:lnSpc>
-                      </a:pPr>
-                      <a:r>
-                        <a:rPr sz="560" b="0">
-                          <a:solidFill>
-                            <a:srgbClr val="000000"/>
-                          </a:solidFill>
-                          <a:latin typeface="Ubuntu Mono"/>
-                          <a:ea typeface="Ubuntu Mono"/>
-                          <a:cs typeface="Ubuntu Mono"/>
-                          <a:sym typeface="Ubuntu Mono"/>
-                        </a:rPr>
-                        <a:t>9-1/2</a:t>
-                      </a:r>
-                    </a:p>
-                  </a:txBody>
-                  <a:tcPr marL="27940" marR="27940" marT="15240" marB="15240" anchor="ctr">
-                    <a:lnL w="4762" cap="flat" cmpd="sng" algn="ctr">
-                      <a:solidFill>
-                        <a:srgbClr val="000000"/>
-                      </a:solidFill>
-                      <a:prstDash val="solid"/>
-                    </a:lnL>
-                    <a:lnR w="4762" cap="flat" cmpd="sng" algn="ctr">
-                      <a:solidFill>
-                        <a:srgbClr val="000000"/>
-                      </a:solidFill>
-                      <a:prstDash val="solid"/>
-                    </a:lnR>
-                    <a:lnT w="4762" cap="flat" cmpd="sng" algn="ctr">
-                      <a:solidFill>
-                        <a:srgbClr val="000000"/>
-                      </a:solidFill>
-                      <a:prstDash val="solid"/>
-                    </a:lnT>
-                    <a:lnB w="4762" cap="flat" cmpd="sng" algn="ctr">
-                      <a:solidFill>
-                        <a:srgbClr val="000000"/>
-                      </a:solidFill>
-                      <a:prstDash val="solid"/>
-                    </a:lnB>
-                    <a:solidFill>
-                      <a:srgbClr val="EEF6FD"/>
-                    </a:solidFill>
-                  </a:tcPr>
-                </a:tc>
-                <a:tc>
-                  <a:txBody>
-                    <a:bodyPr wrap="square"/>
-                    <a:lstStyle/>
-                    <a:p>
-                      <a:pPr algn="ctr">
-                        <a:lnSpc>
-                          <a:spcPts val="719"/>
-                        </a:lnSpc>
-                      </a:pPr>
-                      <a:r>
-                        <a:rPr sz="560" b="0">
-                          <a:solidFill>
-                            <a:srgbClr val="000000"/>
-                          </a:solidFill>
-                          <a:latin typeface="Ubuntu Mono"/>
-                          <a:ea typeface="Ubuntu Mono"/>
-                          <a:cs typeface="Ubuntu Mono"/>
-                          <a:sym typeface="Ubuntu Mono"/>
-                        </a:rPr>
-                        <a:t>915</a:t>
-                      </a:r>
-                    </a:p>
-                  </a:txBody>
-                  <a:tcPr marL="27940" marR="27940" marT="15240" marB="15240" anchor="ctr">
-                    <a:lnL w="4762" cap="flat" cmpd="sng" algn="ctr">
-                      <a:solidFill>
-                        <a:srgbClr val="000000"/>
-                      </a:solidFill>
-                      <a:prstDash val="solid"/>
-                    </a:lnL>
-                    <a:lnR w="4762" cap="flat" cmpd="sng" algn="ctr">
-                      <a:solidFill>
-                        <a:srgbClr val="000000"/>
-                      </a:solidFill>
-                      <a:prstDash val="solid"/>
-                    </a:lnR>
-                    <a:lnT w="4762" cap="flat" cmpd="sng" algn="ctr">
-                      <a:solidFill>
-                        <a:srgbClr val="000000"/>
-                      </a:solidFill>
-                      <a:prstDash val="solid"/>
-                    </a:lnT>
-                    <a:lnB w="4762" cap="flat" cmpd="sng" algn="ctr">
-                      <a:solidFill>
-                        <a:srgbClr val="000000"/>
-                      </a:solidFill>
-                      <a:prstDash val="solid"/>
-                    </a:lnB>
-                    <a:solidFill>
-                      <a:srgbClr val="EEF6FD"/>
-                    </a:solidFill>
-                  </a:tcPr>
-                </a:tc>
-              </a:tr>
-              <a:tr h="139700">
-                <a:tc>
-                  <a:txBody>
-                    <a:bodyPr wrap="square"/>
-                    <a:lstStyle/>
-                    <a:p>
-                      <a:pPr algn="ctr">
-                        <a:lnSpc>
-                          <a:spcPts val="719"/>
-                        </a:lnSpc>
-                      </a:pPr>
-                      <a:r>
-                        <a:rPr sz="560" b="0">
-                          <a:solidFill>
-                            <a:srgbClr val="FEFEFF"/>
-                          </a:solidFill>
-                          <a:latin typeface="Ubuntu Mono"/>
-                          <a:ea typeface="Ubuntu Mono"/>
-                          <a:cs typeface="Ubuntu Mono"/>
-                          <a:sym typeface="Ubuntu Mono"/>
-                        </a:rPr>
-                        <a:t>11000</a:t>
-                      </a:r>
-                    </a:p>
-                  </a:txBody>
-                  <a:tcPr marL="27940" marR="27940" marT="15240" marB="15240" anchor="ctr">
-                    <a:lnL w="4762" cap="flat" cmpd="sng" algn="ctr">
-                      <a:solidFill>
-                        <a:srgbClr val="000000"/>
-                      </a:solidFill>
-                      <a:prstDash val="solid"/>
-                    </a:lnL>
-                    <a:lnR w="4762" cap="flat" cmpd="sng" algn="ctr">
-                      <a:solidFill>
-                        <a:srgbClr val="000000"/>
-                      </a:solidFill>
-                      <a:prstDash val="solid"/>
-                    </a:lnR>
-                    <a:lnT w="4762" cap="flat" cmpd="sng" algn="ctr">
-                      <a:solidFill>
-                        <a:srgbClr val="000000"/>
-                      </a:solidFill>
-                      <a:prstDash val="solid"/>
-                    </a:lnT>
-                    <a:lnB w="4762" cap="flat" cmpd="sng" algn="ctr">
-                      <a:solidFill>
-                        <a:srgbClr val="000000"/>
-                      </a:solidFill>
-                      <a:prstDash val="solid"/>
-                    </a:lnB>
-                    <a:solidFill>
-                      <a:srgbClr val="194E9A"/>
-                    </a:solidFill>
-                  </a:tcPr>
-                </a:tc>
-                <a:tc>
-                  <a:txBody>
-                    <a:bodyPr wrap="square"/>
-                    <a:lstStyle/>
-                    <a:p>
-                      <a:pPr algn="ctr">
-                        <a:lnSpc>
-                          <a:spcPts val="719"/>
-                        </a:lnSpc>
-                      </a:pPr>
-                      <a:r>
-                        <a:rPr sz="560" b="0">
-                          <a:solidFill>
-                            <a:srgbClr val="000000"/>
-                          </a:solidFill>
-                          <a:latin typeface="Ubuntu Mono"/>
-                          <a:ea typeface="Ubuntu Mono"/>
-                          <a:cs typeface="Ubuntu Mono"/>
-                          <a:sym typeface="Ubuntu Mono"/>
-                        </a:rPr>
-                        <a:t>17-1/2, 22-5/8</a:t>
-                      </a:r>
-                    </a:p>
-                  </a:txBody>
-                  <a:tcPr marL="27940" marR="27940" marT="15240" marB="15240" anchor="ctr">
-                    <a:lnL w="4762" cap="flat" cmpd="sng" algn="ctr">
-                      <a:solidFill>
-                        <a:srgbClr val="000000"/>
-                      </a:solidFill>
-                      <a:prstDash val="solid"/>
-                    </a:lnL>
-                    <a:lnR w="4762" cap="flat" cmpd="sng" algn="ctr">
-                      <a:solidFill>
-                        <a:srgbClr val="000000"/>
-                      </a:solidFill>
-                      <a:prstDash val="solid"/>
-                    </a:lnR>
-                    <a:lnT w="4762" cap="flat" cmpd="sng" algn="ctr">
-                      <a:solidFill>
-                        <a:srgbClr val="000000"/>
-                      </a:solidFill>
-                      <a:prstDash val="solid"/>
-                    </a:lnT>
-                    <a:lnB w="4762" cap="flat" cmpd="sng" algn="ctr">
-                      <a:solidFill>
-                        <a:srgbClr val="000000"/>
-                      </a:solidFill>
-                      <a:prstDash val="solid"/>
-                    </a:lnB>
-                    <a:solidFill>
-                      <a:srgbClr val="FFFFFF"/>
-                    </a:solidFill>
-                  </a:tcPr>
-                </a:tc>
-                <a:tc>
-                  <a:txBody>
-                    <a:bodyPr wrap="square"/>
-                    <a:lstStyle/>
-                    <a:p>
-                      <a:pPr algn="ctr">
-                        <a:lnSpc>
-                          <a:spcPts val="719"/>
-                        </a:lnSpc>
-                      </a:pPr>
-                      <a:r>
-                        <a:rPr sz="560" b="0">
-                          <a:solidFill>
-                            <a:srgbClr val="000000"/>
-                          </a:solidFill>
-                          <a:latin typeface="Ubuntu Mono"/>
-                          <a:ea typeface="Ubuntu Mono"/>
-                          <a:cs typeface="Ubuntu Mono"/>
-                          <a:sym typeface="Ubuntu Mono"/>
-                        </a:rPr>
-                        <a:t>9-1/2</a:t>
-                      </a:r>
-                    </a:p>
-                  </a:txBody>
-                  <a:tcPr marL="27940" marR="27940" marT="15240" marB="15240" anchor="ctr">
-                    <a:lnL w="4762" cap="flat" cmpd="sng" algn="ctr">
-                      <a:solidFill>
-                        <a:srgbClr val="000000"/>
-                      </a:solidFill>
-                      <a:prstDash val="solid"/>
-                    </a:lnL>
-                    <a:lnR w="4762" cap="flat" cmpd="sng" algn="ctr">
-                      <a:solidFill>
-                        <a:srgbClr val="000000"/>
-                      </a:solidFill>
-                      <a:prstDash val="solid"/>
-                    </a:lnR>
-                    <a:lnT w="4762" cap="flat" cmpd="sng" algn="ctr">
-                      <a:solidFill>
-                        <a:srgbClr val="000000"/>
-                      </a:solidFill>
-                      <a:prstDash val="solid"/>
-                    </a:lnT>
-                    <a:lnB w="4762" cap="flat" cmpd="sng" algn="ctr">
-                      <a:solidFill>
-                        <a:srgbClr val="000000"/>
-                      </a:solidFill>
-                      <a:prstDash val="solid"/>
-                    </a:lnB>
-                    <a:solidFill>
-                      <a:srgbClr val="FFFFFF"/>
-                    </a:solidFill>
-                  </a:tcPr>
-                </a:tc>
-                <a:tc>
-                  <a:txBody>
-                    <a:bodyPr wrap="square"/>
-                    <a:lstStyle/>
-                    <a:p>
-                      <a:pPr algn="ctr">
-                        <a:lnSpc>
-                          <a:spcPts val="719"/>
-                        </a:lnSpc>
-                      </a:pPr>
-                      <a:r>
-                        <a:rPr sz="560" b="0">
-                          <a:solidFill>
-                            <a:srgbClr val="000000"/>
-                          </a:solidFill>
-                          <a:latin typeface="Ubuntu Mono"/>
-                          <a:ea typeface="Ubuntu Mono"/>
-                          <a:cs typeface="Ubuntu Mono"/>
-                          <a:sym typeface="Ubuntu Mono"/>
-                        </a:rPr>
-                        <a:t>11-5/8</a:t>
-                      </a:r>
-                    </a:p>
-                  </a:txBody>
-                  <a:tcPr marL="27940" marR="27940" marT="15240" marB="15240" anchor="ctr">
-                    <a:lnL w="4762" cap="flat" cmpd="sng" algn="ctr">
-                      <a:solidFill>
-                        <a:srgbClr val="000000"/>
-                      </a:solidFill>
-                      <a:prstDash val="solid"/>
-                    </a:lnL>
-                    <a:lnR w="4762" cap="flat" cmpd="sng" algn="ctr">
-                      <a:solidFill>
-                        <a:srgbClr val="000000"/>
-                      </a:solidFill>
-                      <a:prstDash val="solid"/>
-                    </a:lnR>
-                    <a:lnT w="4762" cap="flat" cmpd="sng" algn="ctr">
-                      <a:solidFill>
-                        <a:srgbClr val="000000"/>
-                      </a:solidFill>
-                      <a:prstDash val="solid"/>
-                    </a:lnT>
-                    <a:lnB w="4762" cap="flat" cmpd="sng" algn="ctr">
-                      <a:solidFill>
-                        <a:srgbClr val="000000"/>
-                      </a:solidFill>
-                      <a:prstDash val="solid"/>
-                    </a:lnB>
-                    <a:solidFill>
-                      <a:srgbClr val="FFFFFF"/>
-                    </a:solidFill>
-                  </a:tcPr>
-                </a:tc>
-                <a:tc>
-                  <a:txBody>
-                    <a:bodyPr wrap="square"/>
-                    <a:lstStyle/>
-                    <a:p>
-                      <a:pPr algn="ctr">
-                        <a:lnSpc>
-                          <a:spcPts val="719"/>
-                        </a:lnSpc>
-                      </a:pPr>
-                      <a:r>
-                        <a:rPr sz="560" b="0">
-                          <a:solidFill>
-                            <a:srgbClr val="000000"/>
-                          </a:solidFill>
-                          <a:latin typeface="Ubuntu Mono"/>
-                          <a:ea typeface="Ubuntu Mono"/>
-                          <a:cs typeface="Ubuntu Mono"/>
-                          <a:sym typeface="Ubuntu Mono"/>
-                        </a:rPr>
-                        <a:t>1,100</a:t>
-                      </a:r>
-                    </a:p>
-                  </a:txBody>
-                  <a:tcPr marL="27940" marR="27940" marT="15240" marB="15240" anchor="ctr">
-                    <a:lnL w="4762" cap="flat" cmpd="sng" algn="ctr">
-                      <a:solidFill>
-                        <a:srgbClr val="000000"/>
-                      </a:solidFill>
-                      <a:prstDash val="solid"/>
-                    </a:lnL>
-                    <a:lnR w="4762" cap="flat" cmpd="sng" algn="ctr">
-                      <a:solidFill>
-                        <a:srgbClr val="000000"/>
-                      </a:solidFill>
-                      <a:prstDash val="solid"/>
-                    </a:lnR>
-                    <a:lnT w="4762" cap="flat" cmpd="sng" algn="ctr">
-                      <a:solidFill>
-                        <a:srgbClr val="000000"/>
-                      </a:solidFill>
-                      <a:prstDash val="solid"/>
-                    </a:lnT>
-                    <a:lnB w="4762" cap="flat" cmpd="sng" algn="ctr">
-                      <a:solidFill>
-                        <a:srgbClr val="000000"/>
-                      </a:solidFill>
-                      <a:prstDash val="solid"/>
-                    </a:lnB>
-                    <a:solidFill>
-                      <a:srgbClr val="FFFFFF"/>
-                    </a:solidFill>
-                  </a:tcPr>
-                </a:tc>
-              </a:tr>
-              <a:tr h="139700">
-                <a:tc>
-                  <a:txBody>
-                    <a:bodyPr wrap="square"/>
-                    <a:lstStyle/>
-                    <a:p>
-                      <a:pPr algn="ctr">
-                        <a:lnSpc>
-                          <a:spcPts val="719"/>
-                        </a:lnSpc>
-                      </a:pPr>
-                      <a:r>
-                        <a:rPr sz="560" b="0">
-                          <a:solidFill>
-                            <a:srgbClr val="FEFEFF"/>
-                          </a:solidFill>
-                          <a:latin typeface="Ubuntu Mono"/>
-                          <a:ea typeface="Ubuntu Mono"/>
-                          <a:cs typeface="Ubuntu Mono"/>
-                          <a:sym typeface="Ubuntu Mono"/>
-                        </a:rPr>
-                        <a:t>15000</a:t>
-                      </a:r>
-                    </a:p>
-                  </a:txBody>
-                  <a:tcPr marL="27940" marR="27940" marT="15240" marB="15240" anchor="ctr">
-                    <a:lnL w="4762" cap="flat" cmpd="sng" algn="ctr">
-                      <a:solidFill>
-                        <a:srgbClr val="000000"/>
-                      </a:solidFill>
-                      <a:prstDash val="solid"/>
-                    </a:lnL>
-                    <a:lnR w="4762" cap="flat" cmpd="sng" algn="ctr">
-                      <a:solidFill>
-                        <a:srgbClr val="000000"/>
-                      </a:solidFill>
-                      <a:prstDash val="solid"/>
-                    </a:lnR>
-                    <a:lnT w="4762" cap="flat" cmpd="sng" algn="ctr">
-                      <a:solidFill>
-                        <a:srgbClr val="000000"/>
-                      </a:solidFill>
-                      <a:prstDash val="solid"/>
-                    </a:lnT>
-                    <a:lnB w="4762" cap="flat" cmpd="sng" algn="ctr">
-                      <a:solidFill>
-                        <a:srgbClr val="000000"/>
-                      </a:solidFill>
-                      <a:prstDash val="solid"/>
-                    </a:lnB>
-                    <a:solidFill>
-                      <a:srgbClr val="01ADEE"/>
-                    </a:solidFill>
-                  </a:tcPr>
-                </a:tc>
-                <a:tc>
-                  <a:txBody>
-                    <a:bodyPr wrap="square"/>
-                    <a:lstStyle/>
-                    <a:p>
-                      <a:pPr algn="ctr">
-                        <a:lnSpc>
-                          <a:spcPts val="719"/>
-                        </a:lnSpc>
-                      </a:pPr>
-                      <a:r>
-                        <a:rPr sz="560" b="0">
-                          <a:solidFill>
-                            <a:srgbClr val="000000"/>
-                          </a:solidFill>
-                          <a:latin typeface="Ubuntu Mono"/>
-                          <a:ea typeface="Ubuntu Mono"/>
-                          <a:cs typeface="Ubuntu Mono"/>
-                          <a:sym typeface="Ubuntu Mono"/>
-                        </a:rPr>
-                        <a:t>17-1/2, 26-5/8, 36-5/8</a:t>
-                      </a:r>
-                    </a:p>
-                  </a:txBody>
-                  <a:tcPr marL="27940" marR="27940" marT="15240" marB="15240" anchor="ctr">
-                    <a:lnL w="4762" cap="flat" cmpd="sng" algn="ctr">
-                      <a:solidFill>
-                        <a:srgbClr val="000000"/>
-                      </a:solidFill>
-                      <a:prstDash val="solid"/>
-                    </a:lnL>
-                    <a:lnR w="4762" cap="flat" cmpd="sng" algn="ctr">
-                      <a:solidFill>
-                        <a:srgbClr val="000000"/>
-                      </a:solidFill>
-                      <a:prstDash val="solid"/>
-                    </a:lnR>
-                    <a:lnT w="4762" cap="flat" cmpd="sng" algn="ctr">
-                      <a:solidFill>
-                        <a:srgbClr val="000000"/>
-                      </a:solidFill>
-                      <a:prstDash val="solid"/>
-                    </a:lnT>
-                    <a:lnB w="4762" cap="flat" cmpd="sng" algn="ctr">
-                      <a:solidFill>
-                        <a:srgbClr val="000000"/>
-                      </a:solidFill>
-                      <a:prstDash val="solid"/>
-                    </a:lnB>
-                    <a:solidFill>
-                      <a:srgbClr val="EEF6FD"/>
-                    </a:solidFill>
-                  </a:tcPr>
-                </a:tc>
-                <a:tc>
-                  <a:txBody>
-                    <a:bodyPr wrap="square"/>
-                    <a:lstStyle/>
-                    <a:p>
-                      <a:pPr algn="ctr">
-                        <a:lnSpc>
-                          <a:spcPts val="719"/>
-                        </a:lnSpc>
-                      </a:pPr>
-                      <a:r>
-                        <a:rPr sz="560" b="0">
-                          <a:solidFill>
-                            <a:srgbClr val="000000"/>
-                          </a:solidFill>
-                          <a:latin typeface="Ubuntu Mono"/>
-                          <a:ea typeface="Ubuntu Mono"/>
-                          <a:cs typeface="Ubuntu Mono"/>
-                          <a:sym typeface="Ubuntu Mono"/>
-                        </a:rPr>
-                        <a:t>9-1/2, 12-1/4, 24-5/8</a:t>
-                      </a:r>
-                    </a:p>
-                  </a:txBody>
-                  <a:tcPr marL="27940" marR="27940" marT="15240" marB="15240" anchor="ctr">
-                    <a:lnL w="4762" cap="flat" cmpd="sng" algn="ctr">
-                      <a:solidFill>
-                        <a:srgbClr val="000000"/>
-                      </a:solidFill>
-                      <a:prstDash val="solid"/>
-                    </a:lnL>
-                    <a:lnR w="4762" cap="flat" cmpd="sng" algn="ctr">
-                      <a:solidFill>
-                        <a:srgbClr val="000000"/>
-                      </a:solidFill>
-                      <a:prstDash val="solid"/>
-                    </a:lnR>
-                    <a:lnT w="4762" cap="flat" cmpd="sng" algn="ctr">
-                      <a:solidFill>
-                        <a:srgbClr val="000000"/>
-                      </a:solidFill>
-                      <a:prstDash val="solid"/>
-                    </a:lnT>
-                    <a:lnB w="4762" cap="flat" cmpd="sng" algn="ctr">
-                      <a:solidFill>
-                        <a:srgbClr val="000000"/>
-                      </a:solidFill>
-                      <a:prstDash val="solid"/>
-                    </a:lnB>
-                    <a:solidFill>
-                      <a:srgbClr val="EEF6FD"/>
-                    </a:solidFill>
-                  </a:tcPr>
-                </a:tc>
-                <a:tc>
-                  <a:txBody>
-                    <a:bodyPr wrap="square"/>
-                    <a:lstStyle/>
-                    <a:p>
-                      <a:pPr algn="ctr">
-                        <a:lnSpc>
-                          <a:spcPts val="719"/>
-                        </a:lnSpc>
-                      </a:pPr>
-                      <a:r>
-                        <a:rPr sz="560" b="0">
-                          <a:solidFill>
-                            <a:srgbClr val="000000"/>
-                          </a:solidFill>
-                          <a:latin typeface="Ubuntu Mono"/>
-                          <a:ea typeface="Ubuntu Mono"/>
-                          <a:cs typeface="Ubuntu Mono"/>
-                          <a:sym typeface="Ubuntu Mono"/>
-                        </a:rPr>
-                        <a:t>15-5/8</a:t>
-                      </a:r>
-                    </a:p>
-                  </a:txBody>
-                  <a:tcPr marL="27940" marR="27940" marT="15240" marB="15240" anchor="ctr">
-                    <a:lnL w="4762" cap="flat" cmpd="sng" algn="ctr">
-                      <a:solidFill>
-                        <a:srgbClr val="000000"/>
-                      </a:solidFill>
-                      <a:prstDash val="solid"/>
-                    </a:lnL>
-                    <a:lnR w="4762" cap="flat" cmpd="sng" algn="ctr">
-                      <a:solidFill>
-                        <a:srgbClr val="000000"/>
-                      </a:solidFill>
-                      <a:prstDash val="solid"/>
-                    </a:lnR>
-                    <a:lnT w="4762" cap="flat" cmpd="sng" algn="ctr">
-                      <a:solidFill>
-                        <a:srgbClr val="000000"/>
-                      </a:solidFill>
-                      <a:prstDash val="solid"/>
-                    </a:lnT>
-                    <a:lnB w="4762" cap="flat" cmpd="sng" algn="ctr">
-                      <a:solidFill>
-                        <a:srgbClr val="000000"/>
-                      </a:solidFill>
-                      <a:prstDash val="solid"/>
-                    </a:lnB>
-                    <a:solidFill>
-                      <a:srgbClr val="EEF6FD"/>
-                    </a:solidFill>
-                  </a:tcPr>
-                </a:tc>
-                <a:tc>
-                  <a:txBody>
-                    <a:bodyPr wrap="square"/>
-                    <a:lstStyle/>
-                    <a:p>
-                      <a:pPr algn="ctr">
-                        <a:lnSpc>
-                          <a:spcPts val="719"/>
-                        </a:lnSpc>
-                      </a:pPr>
-                      <a:r>
-                        <a:rPr sz="560" b="0">
-                          <a:solidFill>
-                            <a:srgbClr val="000000"/>
-                          </a:solidFill>
-                          <a:latin typeface="Ubuntu Mono"/>
-                          <a:ea typeface="Ubuntu Mono"/>
-                          <a:cs typeface="Ubuntu Mono"/>
-                          <a:sym typeface="Ubuntu Mono"/>
-                        </a:rPr>
-                        <a:t>1,900</a:t>
-                      </a:r>
-                    </a:p>
-                  </a:txBody>
-                  <a:tcPr marL="27940" marR="27940" marT="15240" marB="15240" anchor="ctr">
-                    <a:lnL w="4762" cap="flat" cmpd="sng" algn="ctr">
-                      <a:solidFill>
-                        <a:srgbClr val="000000"/>
-                      </a:solidFill>
-                      <a:prstDash val="solid"/>
-                    </a:lnL>
-                    <a:lnR w="4762" cap="flat" cmpd="sng" algn="ctr">
-                      <a:solidFill>
-                        <a:srgbClr val="000000"/>
-                      </a:solidFill>
-                      <a:prstDash val="solid"/>
-                    </a:lnR>
-                    <a:lnT w="4762" cap="flat" cmpd="sng" algn="ctr">
-                      <a:solidFill>
-                        <a:srgbClr val="000000"/>
-                      </a:solidFill>
-                      <a:prstDash val="solid"/>
-                    </a:lnT>
-                    <a:lnB w="4762" cap="flat" cmpd="sng" algn="ctr">
-                      <a:solidFill>
-                        <a:srgbClr val="000000"/>
-                      </a:solidFill>
-                      <a:prstDash val="solid"/>
-                    </a:lnB>
-                    <a:solidFill>
-                      <a:srgbClr val="EEF6FD"/>
-                    </a:solidFill>
-                  </a:tcPr>
-                </a:tc>
-              </a:tr>
-            </a:tbl>
-          </a:graphicData>
-        </a:graphic>
-      </p:graphicFrame>
       <p:sp>
         <p:nvSpPr>
-          <p:cNvPr id="38" name="TextBox 37"/>
+          <p:cNvPr id="37" name="TextBox 36"/>
           <p:cNvSpPr txBox="1"/>
           <p:nvPr/>
         </p:nvSpPr>
         <p:spPr>
           <a:xfrm>
-            <a:off x="2260600" y="10007600"/>
-            <a:ext cx="1778000" cy="177800"/>
+            <a:off x="4089400" y="9753600"/>
+            <a:ext cx="2755900" cy="177800"/>
           </a:xfrm>
           <a:prstGeom prst="rect">
             <a:avLst/>
@@ -13132,14 +11745,14 @@
       </p:sp>
       <p:sp>
         <p:nvSpPr>
-          <p:cNvPr id="39" name="TextBox 38"/>
+          <p:cNvPr id="38" name="TextBox 37"/>
           <p:cNvSpPr txBox="1"/>
           <p:nvPr/>
         </p:nvSpPr>
         <p:spPr>
           <a:xfrm>
-            <a:off x="2260600" y="10185400"/>
-            <a:ext cx="1778000" cy="762000"/>
+            <a:off x="4089400" y="9931400"/>
+            <a:ext cx="2755900" cy="635000"/>
           </a:xfrm>
           <a:prstGeom prst="rect">
             <a:avLst/>

</xml_diff>